<commit_message>
docs: adiciona apresentação e roteiro de fala do frontend
</commit_message>
<xml_diff>
--- a/docs/AutoAudit_Frontend_Apresentacao.pptx
+++ b/docs/AutoAudit_Frontend_Apresentacao.pptx
@@ -117,18 +117,18 @@
   <p:extLst>
     <p:ext uri="{521415D9-36F7-43E2-AB2F-B90AF26B5E84}">
       <p14:sectionLst xmlns:p14="http://schemas.microsoft.com/office/powerpoint/2010/main">
-        <p14:section name="Abertura" id="{1ef38b7a-5f37-b73b-7e5c-6487b8ff1e38}">
+        <p14:section name="Abertura" id="{eaf6b91f-9df6-00bc-220f-6050c5e7c5d4}">
           <p14:sldIdLst>
             <p14:sldId id="256"/>
           </p14:sldIdLst>
         </p14:section>
-        <p14:section name="Contexto" id="{880dc4c1-3d8d-bc60-d1e5-38ae9e5eea07}">
+        <p14:section name="Contexto" id="{ed12f371-620d-f898-605d-f7f0b4e76a16}">
           <p14:sldIdLst>
             <p14:sldId id="257"/>
             <p14:sldId id="258"/>
           </p14:sldIdLst>
         </p14:section>
-        <p14:section name="Telas" id="{fd1c1b78-602f-4166-031e-8a64cda60684}">
+        <p14:section name="Telas" id="{08808bbc-6b9a-c691-a62b-ec77912a7cd7}">
           <p14:sldIdLst>
             <p14:sldId id="259"/>
             <p14:sldId id="260"/>
@@ -136,17 +136,17 @@
             <p14:sldId id="262"/>
           </p14:sldIdLst>
         </p14:section>
-        <p14:section name="Integração" id="{ea9a1245-413b-c5b9-775a-1d2cc35bcb2d}">
+        <p14:section name="Integração" id="{83d02cfb-cf5d-b7e4-dea5-0b420a4eca34}">
           <p14:sldIdLst>
             <p14:sldId id="263"/>
           </p14:sldIdLst>
         </p14:section>
-        <p14:section name="Demonstração" id="{a6496584-dd56-2a17-16f2-15ba2c7bf2b5}">
+        <p14:section name="Demonstração" id="{bdffbb54-4db9-ac7d-1b05-f6116bf82612}">
           <p14:sldIdLst>
             <p14:sldId id="264"/>
           </p14:sldIdLst>
         </p14:section>
-        <p14:section name="Fechamento" id="{18dcaf1c-6156-3c65-bbb1-306d168d6280}">
+        <p14:section name="Fechamento" id="{625db775-17ea-67b9-b15d-2a9816c656eb}">
           <p14:sldIdLst>
             <p14:sldId id="265"/>
             <p14:sldId id="266"/>
@@ -1260,7 +1260,7 @@
           <a:p>
             <a:r>
               <a:rPr lang="en-US" dirty="0"/>
-              <a:t>Estados especiais (1 min). Quando a Verificação Prática não é executada, o app trata isso como um estado válido e explica ao usuário. No histórico, hoje a lista vale só para a sessão do navegador; com o backend conectado ao MongoDB ela passa a ser permanente.</a:t>
+              <a:t>Estados especiais (1 min). Quando a Verificação Prática não é executada, o app trata isso como um estado válido e explica ao usuário. No histórico, o gráfico de evolução é uma prévia: na versão final ele compara versões da mesma política ao longo do tempo. Hoje a lista vale só para a sessão do navegador; com o backend conectado ao MongoDB ela passa a ser permanente.</a:t>
             </a:r>
             <a:endParaRPr lang="en-US" dirty="0"/>
           </a:p>
@@ -6669,7 +6669,7 @@
                   <a:schemeClr val="tx1"/>
                 </a:solidFill>
               </a:rPr>
-              <a:t>Histórico: tabela das auditorias, gráfico de evolução da nota e reabertura de qualquer resultado.</a:t>
+              <a:t>Histórico: tabela das auditorias, prévia do gráfico de evolução (na versão final, por política) e reabertura de qualquer resultado.</a:t>
             </a:r>
             <a:endParaRPr lang="en-US" sz="1300" dirty="0"/>
           </a:p>

</xml_diff>